<commit_message>
Renovar la fotografía del PPT del 20 de septiembre
</commit_message>
<xml_diff>
--- a/assets/presentations/2026-09-20-todo-este-tiempo-contigo.pptx
+++ b/assets/presentations/2026-09-20-todo-este-tiempo-contigo.pptx
@@ -2,15 +2,15 @@
 <file path=ppt/presentation.xml><?xml version="1.0" encoding="utf-8"?>
 <p:presentation xmlns:p="http://schemas.openxmlformats.org/presentationml/2006/main">
   <p:sldMasterIdLst>
-    <p:sldMasterId xmlns:r="http://schemas.openxmlformats.org/officeDocument/2006/relationships" id="2147483648" r:id="R1211325f74f6430c"/>
+    <p:sldMasterId xmlns:r="http://schemas.openxmlformats.org/officeDocument/2006/relationships" id="2147483648" r:id="Rfb494424a6d24291"/>
   </p:sldMasterIdLst>
   <p:notesMasterIdLst>
-    <p:notesMasterId xmlns:r="http://schemas.openxmlformats.org/officeDocument/2006/relationships" r:id="R7265712301b34823"/>
+    <p:notesMasterId xmlns:r="http://schemas.openxmlformats.org/officeDocument/2006/relationships" r:id="Rff38c041f03342e4"/>
   </p:notesMasterIdLst>
   <p:sldIdLst>
-    <p:sldId xmlns:r="http://schemas.openxmlformats.org/officeDocument/2006/relationships" id="256" r:id="R7509e2e529f949bb"/>
-    <p:sldId xmlns:r="http://schemas.openxmlformats.org/officeDocument/2006/relationships" id="257" r:id="Re02233ff09354b3c"/>
-    <p:sldId xmlns:r="http://schemas.openxmlformats.org/officeDocument/2006/relationships" id="258" r:id="Rc198a84e74d34f63"/>
+    <p:sldId xmlns:r="http://schemas.openxmlformats.org/officeDocument/2006/relationships" id="256" r:id="R2456c867ee4c4387"/>
+    <p:sldId xmlns:r="http://schemas.openxmlformats.org/officeDocument/2006/relationships" id="257" r:id="Rc1ed81c510f642ce"/>
+    <p:sldId xmlns:r="http://schemas.openxmlformats.org/officeDocument/2006/relationships" id="258" r:id="R709f5c40cb4f4252"/>
   </p:sldIdLst>
   <p:sldSz cx="12192000" cy="6858000"/>
   <p:notesSz cx="6858000" cy="9144000"/>
@@ -792,7 +792,7 @@
   </p:cSld>
   <p:clrMap bg1="lt1" tx1="dk1" bg2="lt2" tx2="dk2" accent1="accent1" accent2="accent2" accent3="accent3" accent4="accent4" accent5="accent5" accent6="accent6" hlink="hlink" folHlink="folHlink"/>
   <p:sldLayoutIdLst>
-    <p:sldLayoutId xmlns:r="http://schemas.openxmlformats.org/officeDocument/2006/relationships" id="2147483649" r:id="Rbe80503fb38a4591"/>
+    <p:sldLayoutId xmlns:r="http://schemas.openxmlformats.org/officeDocument/2006/relationships" id="2147483649" r:id="R904974f2fbde455c"/>
   </p:sldLayoutIdLst>
   <p:txStyles>
     <p:titleStyle>
@@ -1340,7 +1340,7 @@
           <p:nvPr/>
         </p:nvPicPr>
         <p:blipFill>
-          <a:blip xmlns:r="http://schemas.openxmlformats.org/officeDocument/2006/relationships" xmlns:a="http://schemas.openxmlformats.org/drawingml/2006/main" r:embed="Rf292c25479e44b59"/>
+          <a:blip xmlns:r="http://schemas.openxmlformats.org/officeDocument/2006/relationships" xmlns:a="http://schemas.openxmlformats.org/drawingml/2006/main" r:embed="R7b3bb241ef424a2c"/>
           <a:srcRect xmlns:a="http://schemas.openxmlformats.org/drawingml/2006/main" l="0" t="27" r="0" b="27"/>
           <a:stretch xmlns:a="http://schemas.openxmlformats.org/drawingml/2006/main">
             <a:fillRect l="0" t="0" r="0" b="0"/>

</xml_diff>